<commit_message>
Add security & privacy appendix to pitch deck (17 slides)
Appendix 1 — Databeveiliging & Architectuur:
- 5 security layers (auth, RLS, HTTPS, storage, BSN masking)
- Side-by-side: risks of physical mail vs portal safeguards
- Physical mail has no access control, audit trail, or encryption
- Portal enforces authentication, RLS, signed URLs, login logging

Appendix 2 — AVG-compliance & Privacy:
- Maps 5 GDPR articles to portal features
- Right to access: portal provides 24/7 self-service
- Right to rectification: change requests with approval flow
- Data minimisation: BSN masked, only relevant data shown
- Security: encryption, hashing, RLS
- Accountability: full audit trail on logins and changes

Co-Authored-By: Claude Opus 4.6 (1M context) <noreply@anthropic.com>
</commit_message>
<xml_diff>
--- a/pitch/Auteursportaal_Pitch.pptx
+++ b/pitch/Auteursportaal_Pitch.pptx
@@ -20,6 +20,8 @@
     <p:sldId id="268" r:id="rId19"/>
     <p:sldId id="269" r:id="rId20"/>
     <p:sldId id="270" r:id="rId21"/>
+    <p:sldId id="271" r:id="rId22"/>
+    <p:sldId id="272" r:id="rId23"/>
   </p:sldIdLst>
   <p:sldSz cx="12191695" cy="6858000" type="screen4x3"/>
   <p:notesSz cx="6858000" cy="9144000"/>
@@ -9404,6 +9406,2499 @@
 </p:sld>
 </file>
 
+<file path=ppt/slides/slide16.xml><?xml version="1.0" encoding="utf-8"?>
+<p:sld xmlns:a="http://schemas.openxmlformats.org/drawingml/2006/main" xmlns:p="http://schemas.openxmlformats.org/presentationml/2006/main" xmlns:r="http://schemas.openxmlformats.org/officeDocument/2006/relationships">
+  <p:cSld>
+    <p:bg>
+      <p:bgPr>
+        <a:solidFill>
+          <a:srgbClr val="FFFFFF"/>
+        </a:solidFill>
+        <a:effectLst/>
+      </p:bgPr>
+    </p:bg>
+    <p:spTree>
+      <p:nvGrpSpPr>
+        <p:cNvPr id="1" name=""/>
+        <p:cNvGrpSpPr/>
+        <p:nvPr/>
+      </p:nvGrpSpPr>
+      <p:grpSpPr/>
+      <p:sp>
+        <p:nvSpPr>
+          <p:cNvPr id="2" name="TextBox 1"/>
+          <p:cNvSpPr txBox="1"/>
+          <p:nvPr/>
+        </p:nvSpPr>
+        <p:spPr>
+          <a:xfrm>
+            <a:off x="1097280" y="640080"/>
+            <a:ext cx="2743200" cy="274320"/>
+          </a:xfrm>
+          <a:prstGeom prst="rect">
+            <a:avLst/>
+          </a:prstGeom>
+          <a:noFill/>
+        </p:spPr>
+        <p:txBody>
+          <a:bodyPr wrap="square">
+            <a:spAutoFit/>
+          </a:bodyPr>
+          <a:lstStyle/>
+          <a:p>
+            <a:pPr algn="l">
+              <a:defRPr sz="1000" b="1">
+                <a:solidFill>
+                  <a:srgbClr val="6B7280"/>
+                </a:solidFill>
+                <a:latin typeface="Roboto Flex"/>
+              </a:defRPr>
+            </a:pPr>
+            <a:r>
+              <a:t>APPENDIX</a:t>
+            </a:r>
+          </a:p>
+        </p:txBody>
+      </p:sp>
+      <p:sp>
+        <p:nvSpPr>
+          <p:cNvPr id="3" name="TextBox 2"/>
+          <p:cNvSpPr txBox="1"/>
+          <p:nvPr/>
+        </p:nvSpPr>
+        <p:spPr>
+          <a:xfrm>
+            <a:off x="1097280" y="1051560"/>
+            <a:ext cx="10058400" cy="914400"/>
+          </a:xfrm>
+          <a:prstGeom prst="rect">
+            <a:avLst/>
+          </a:prstGeom>
+          <a:noFill/>
+        </p:spPr>
+        <p:txBody>
+          <a:bodyPr wrap="square">
+            <a:spAutoFit/>
+          </a:bodyPr>
+          <a:lstStyle/>
+          <a:p>
+            <a:pPr algn="l">
+              <a:defRPr sz="2800" b="1">
+                <a:solidFill>
+                  <a:srgbClr val="007460"/>
+                </a:solidFill>
+                <a:latin typeface="Roboto Flex"/>
+              </a:defRPr>
+            </a:pPr>
+            <a:r>
+              <a:t>Databeveiliging &amp; Architectuur</a:t>
+            </a:r>
+          </a:p>
+        </p:txBody>
+      </p:sp>
+      <p:sp>
+        <p:nvSpPr>
+          <p:cNvPr id="4" name="TextBox 3"/>
+          <p:cNvSpPr txBox="1"/>
+          <p:nvPr/>
+        </p:nvSpPr>
+        <p:spPr>
+          <a:xfrm>
+            <a:off x="1097280" y="2011680"/>
+            <a:ext cx="4572000" cy="320040"/>
+          </a:xfrm>
+          <a:prstGeom prst="rect">
+            <a:avLst/>
+          </a:prstGeom>
+          <a:noFill/>
+        </p:spPr>
+        <p:txBody>
+          <a:bodyPr wrap="square">
+            <a:spAutoFit/>
+          </a:bodyPr>
+          <a:lstStyle/>
+          <a:p>
+            <a:pPr algn="l">
+              <a:defRPr sz="1400" b="1">
+                <a:solidFill>
+                  <a:srgbClr val="007460"/>
+                </a:solidFill>
+                <a:latin typeface="Roboto Flex"/>
+              </a:defRPr>
+            </a:pPr>
+            <a:r>
+              <a:t>Beveiligingslagen</a:t>
+            </a:r>
+          </a:p>
+        </p:txBody>
+      </p:sp>
+      <p:sp>
+        <p:nvSpPr>
+          <p:cNvPr id="5" name="Oval 4"/>
+          <p:cNvSpPr/>
+          <p:nvPr/>
+        </p:nvSpPr>
+        <p:spPr>
+          <a:xfrm>
+            <a:off x="1280160" y="2496312"/>
+            <a:ext cx="91440" cy="91440"/>
+          </a:xfrm>
+          <a:prstGeom prst="ellipse">
+            <a:avLst/>
+          </a:prstGeom>
+          <a:solidFill>
+            <a:srgbClr val="007460"/>
+          </a:solidFill>
+          <a:ln>
+            <a:noFill/>
+          </a:ln>
+        </p:spPr>
+        <p:style>
+          <a:lnRef idx="1">
+            <a:schemeClr val="accent1"/>
+          </a:lnRef>
+          <a:fillRef idx="3">
+            <a:schemeClr val="accent1"/>
+          </a:fillRef>
+          <a:effectRef idx="2">
+            <a:schemeClr val="accent1"/>
+          </a:effectRef>
+          <a:fontRef idx="minor">
+            <a:schemeClr val="lt1"/>
+          </a:fontRef>
+        </p:style>
+        <p:txBody>
+          <a:bodyPr rtlCol="0" anchor="ctr"/>
+          <a:lstStyle/>
+          <a:p>
+            <a:pPr algn="ctr"/>
+          </a:p>
+        </p:txBody>
+      </p:sp>
+      <p:sp>
+        <p:nvSpPr>
+          <p:cNvPr id="6" name="TextBox 5"/>
+          <p:cNvSpPr txBox="1"/>
+          <p:nvPr/>
+        </p:nvSpPr>
+        <p:spPr>
+          <a:xfrm>
+            <a:off x="1554480" y="2423160"/>
+            <a:ext cx="1645920" cy="274320"/>
+          </a:xfrm>
+          <a:prstGeom prst="rect">
+            <a:avLst/>
+          </a:prstGeom>
+          <a:noFill/>
+        </p:spPr>
+        <p:txBody>
+          <a:bodyPr wrap="square">
+            <a:spAutoFit/>
+          </a:bodyPr>
+          <a:lstStyle/>
+          <a:p>
+            <a:pPr algn="l">
+              <a:defRPr sz="1200" b="1">
+                <a:solidFill>
+                  <a:srgbClr val="111827"/>
+                </a:solidFill>
+                <a:latin typeface="Roboto Flex"/>
+              </a:defRPr>
+            </a:pPr>
+            <a:r>
+              <a:t>Authenticatie</a:t>
+            </a:r>
+          </a:p>
+        </p:txBody>
+      </p:sp>
+      <p:sp>
+        <p:nvSpPr>
+          <p:cNvPr id="7" name="TextBox 6"/>
+          <p:cNvSpPr txBox="1"/>
+          <p:nvPr/>
+        </p:nvSpPr>
+        <p:spPr>
+          <a:xfrm>
+            <a:off x="3291840" y="2423160"/>
+            <a:ext cx="2743200" cy="731520"/>
+          </a:xfrm>
+          <a:prstGeom prst="rect">
+            <a:avLst/>
+          </a:prstGeom>
+          <a:noFill/>
+        </p:spPr>
+        <p:txBody>
+          <a:bodyPr wrap="square">
+            <a:spAutoFit/>
+          </a:bodyPr>
+          <a:lstStyle/>
+          <a:p>
+            <a:pPr algn="l">
+              <a:spcAft>
+                <a:spcPts val="200"/>
+              </a:spcAft>
+              <a:defRPr sz="1000" b="0">
+                <a:solidFill>
+                  <a:srgbClr val="6B7280"/>
+                </a:solidFill>
+                <a:latin typeface="Roboto Flex"/>
+              </a:defRPr>
+            </a:pPr>
+            <a:r>
+              <a:t>Inloggen via Supabase Auth met versleutelde wachtwoorden (bcrypt).</a:t>
+            </a:r>
+          </a:p>
+          <a:p>
+            <a:pPr algn="l">
+              <a:spcAft>
+                <a:spcPts val="200"/>
+              </a:spcAft>
+              <a:defRPr sz="1000" b="0">
+                <a:solidFill>
+                  <a:srgbClr val="6B7280"/>
+                </a:solidFill>
+                <a:latin typeface="Roboto Flex"/>
+              </a:defRPr>
+            </a:pPr>
+            <a:r>
+              <a:t>Sessie-tokens verlopen automatisch. Wachtwoord-reset via beveiligde email.</a:t>
+            </a:r>
+          </a:p>
+        </p:txBody>
+      </p:sp>
+      <p:sp>
+        <p:nvSpPr>
+          <p:cNvPr id="8" name="Oval 7"/>
+          <p:cNvSpPr/>
+          <p:nvPr/>
+        </p:nvSpPr>
+        <p:spPr>
+          <a:xfrm>
+            <a:off x="1280160" y="3319272"/>
+            <a:ext cx="91440" cy="91440"/>
+          </a:xfrm>
+          <a:prstGeom prst="ellipse">
+            <a:avLst/>
+          </a:prstGeom>
+          <a:solidFill>
+            <a:srgbClr val="007460"/>
+          </a:solidFill>
+          <a:ln>
+            <a:noFill/>
+          </a:ln>
+        </p:spPr>
+        <p:style>
+          <a:lnRef idx="1">
+            <a:schemeClr val="accent1"/>
+          </a:lnRef>
+          <a:fillRef idx="3">
+            <a:schemeClr val="accent1"/>
+          </a:fillRef>
+          <a:effectRef idx="2">
+            <a:schemeClr val="accent1"/>
+          </a:effectRef>
+          <a:fontRef idx="minor">
+            <a:schemeClr val="lt1"/>
+          </a:fontRef>
+        </p:style>
+        <p:txBody>
+          <a:bodyPr rtlCol="0" anchor="ctr"/>
+          <a:lstStyle/>
+          <a:p>
+            <a:pPr algn="ctr"/>
+          </a:p>
+        </p:txBody>
+      </p:sp>
+      <p:sp>
+        <p:nvSpPr>
+          <p:cNvPr id="9" name="TextBox 8"/>
+          <p:cNvSpPr txBox="1"/>
+          <p:nvPr/>
+        </p:nvSpPr>
+        <p:spPr>
+          <a:xfrm>
+            <a:off x="1554480" y="3246120"/>
+            <a:ext cx="1645920" cy="274320"/>
+          </a:xfrm>
+          <a:prstGeom prst="rect">
+            <a:avLst/>
+          </a:prstGeom>
+          <a:noFill/>
+        </p:spPr>
+        <p:txBody>
+          <a:bodyPr wrap="square">
+            <a:spAutoFit/>
+          </a:bodyPr>
+          <a:lstStyle/>
+          <a:p>
+            <a:pPr algn="l">
+              <a:defRPr sz="1200" b="1">
+                <a:solidFill>
+                  <a:srgbClr val="111827"/>
+                </a:solidFill>
+                <a:latin typeface="Roboto Flex"/>
+              </a:defRPr>
+            </a:pPr>
+            <a:r>
+              <a:t>Row Level Security</a:t>
+            </a:r>
+          </a:p>
+        </p:txBody>
+      </p:sp>
+      <p:sp>
+        <p:nvSpPr>
+          <p:cNvPr id="10" name="TextBox 9"/>
+          <p:cNvSpPr txBox="1"/>
+          <p:nvPr/>
+        </p:nvSpPr>
+        <p:spPr>
+          <a:xfrm>
+            <a:off x="3291840" y="3246120"/>
+            <a:ext cx="2743200" cy="731520"/>
+          </a:xfrm>
+          <a:prstGeom prst="rect">
+            <a:avLst/>
+          </a:prstGeom>
+          <a:noFill/>
+        </p:spPr>
+        <p:txBody>
+          <a:bodyPr wrap="square">
+            <a:spAutoFit/>
+          </a:bodyPr>
+          <a:lstStyle/>
+          <a:p>
+            <a:pPr algn="l">
+              <a:spcAft>
+                <a:spcPts val="200"/>
+              </a:spcAft>
+              <a:defRPr sz="1000" b="0">
+                <a:solidFill>
+                  <a:srgbClr val="6B7280"/>
+                </a:solidFill>
+                <a:latin typeface="Roboto Flex"/>
+              </a:defRPr>
+            </a:pPr>
+            <a:r>
+              <a:t>De database dwingt af dat elke auteur alleen eigen data ziet.</a:t>
+            </a:r>
+          </a:p>
+          <a:p>
+            <a:pPr algn="l">
+              <a:spcAft>
+                <a:spcPts val="200"/>
+              </a:spcAft>
+              <a:defRPr sz="1000" b="0">
+                <a:solidFill>
+                  <a:srgbClr val="6B7280"/>
+                </a:solidFill>
+                <a:latin typeface="Roboto Flex"/>
+              </a:defRPr>
+            </a:pPr>
+            <a:r>
+              <a:t>Dit is niet afhankelijk van de frontend — zelfs bij directe API-toegang</a:t>
+            </a:r>
+          </a:p>
+          <a:p>
+            <a:pPr algn="l">
+              <a:spcAft>
+                <a:spcPts val="200"/>
+              </a:spcAft>
+              <a:defRPr sz="1000" b="0">
+                <a:solidFill>
+                  <a:srgbClr val="6B7280"/>
+                </a:solidFill>
+                <a:latin typeface="Roboto Flex"/>
+              </a:defRPr>
+            </a:pPr>
+            <a:r>
+              <a:t>wordt alleen eigen data teruggegeven.</a:t>
+            </a:r>
+          </a:p>
+        </p:txBody>
+      </p:sp>
+      <p:sp>
+        <p:nvSpPr>
+          <p:cNvPr id="11" name="Oval 10"/>
+          <p:cNvSpPr/>
+          <p:nvPr/>
+        </p:nvSpPr>
+        <p:spPr>
+          <a:xfrm>
+            <a:off x="1280160" y="4142232"/>
+            <a:ext cx="91440" cy="91440"/>
+          </a:xfrm>
+          <a:prstGeom prst="ellipse">
+            <a:avLst/>
+          </a:prstGeom>
+          <a:solidFill>
+            <a:srgbClr val="007460"/>
+          </a:solidFill>
+          <a:ln>
+            <a:noFill/>
+          </a:ln>
+        </p:spPr>
+        <p:style>
+          <a:lnRef idx="1">
+            <a:schemeClr val="accent1"/>
+          </a:lnRef>
+          <a:fillRef idx="3">
+            <a:schemeClr val="accent1"/>
+          </a:fillRef>
+          <a:effectRef idx="2">
+            <a:schemeClr val="accent1"/>
+          </a:effectRef>
+          <a:fontRef idx="minor">
+            <a:schemeClr val="lt1"/>
+          </a:fontRef>
+        </p:style>
+        <p:txBody>
+          <a:bodyPr rtlCol="0" anchor="ctr"/>
+          <a:lstStyle/>
+          <a:p>
+            <a:pPr algn="ctr"/>
+          </a:p>
+        </p:txBody>
+      </p:sp>
+      <p:sp>
+        <p:nvSpPr>
+          <p:cNvPr id="12" name="TextBox 11"/>
+          <p:cNvSpPr txBox="1"/>
+          <p:nvPr/>
+        </p:nvSpPr>
+        <p:spPr>
+          <a:xfrm>
+            <a:off x="1554480" y="4069080"/>
+            <a:ext cx="1645920" cy="274320"/>
+          </a:xfrm>
+          <a:prstGeom prst="rect">
+            <a:avLst/>
+          </a:prstGeom>
+          <a:noFill/>
+        </p:spPr>
+        <p:txBody>
+          <a:bodyPr wrap="square">
+            <a:spAutoFit/>
+          </a:bodyPr>
+          <a:lstStyle/>
+          <a:p>
+            <a:pPr algn="l">
+              <a:defRPr sz="1200" b="1">
+                <a:solidFill>
+                  <a:srgbClr val="111827"/>
+                </a:solidFill>
+                <a:latin typeface="Roboto Flex"/>
+              </a:defRPr>
+            </a:pPr>
+            <a:r>
+              <a:t>Versleutelde verbinding</a:t>
+            </a:r>
+          </a:p>
+        </p:txBody>
+      </p:sp>
+      <p:sp>
+        <p:nvSpPr>
+          <p:cNvPr id="13" name="TextBox 12"/>
+          <p:cNvSpPr txBox="1"/>
+          <p:nvPr/>
+        </p:nvSpPr>
+        <p:spPr>
+          <a:xfrm>
+            <a:off x="3291840" y="4069080"/>
+            <a:ext cx="2743200" cy="731520"/>
+          </a:xfrm>
+          <a:prstGeom prst="rect">
+            <a:avLst/>
+          </a:prstGeom>
+          <a:noFill/>
+        </p:spPr>
+        <p:txBody>
+          <a:bodyPr wrap="square">
+            <a:spAutoFit/>
+          </a:bodyPr>
+          <a:lstStyle/>
+          <a:p>
+            <a:pPr algn="l">
+              <a:spcAft>
+                <a:spcPts val="200"/>
+              </a:spcAft>
+              <a:defRPr sz="1000" b="0">
+                <a:solidFill>
+                  <a:srgbClr val="6B7280"/>
+                </a:solidFill>
+                <a:latin typeface="Roboto Flex"/>
+              </a:defRPr>
+            </a:pPr>
+            <a:r>
+              <a:t>Alle communicatie verloopt via HTTPS/TLS.</a:t>
+            </a:r>
+          </a:p>
+          <a:p>
+            <a:pPr algn="l">
+              <a:spcAft>
+                <a:spcPts val="200"/>
+              </a:spcAft>
+              <a:defRPr sz="1000" b="0">
+                <a:solidFill>
+                  <a:srgbClr val="6B7280"/>
+                </a:solidFill>
+                <a:latin typeface="Roboto Flex"/>
+              </a:defRPr>
+            </a:pPr>
+            <a:r>
+              <a:t>Data in transit is altijd versleuteld.</a:t>
+            </a:r>
+          </a:p>
+        </p:txBody>
+      </p:sp>
+      <p:sp>
+        <p:nvSpPr>
+          <p:cNvPr id="14" name="Oval 13"/>
+          <p:cNvSpPr/>
+          <p:nvPr/>
+        </p:nvSpPr>
+        <p:spPr>
+          <a:xfrm>
+            <a:off x="1280160" y="4965192"/>
+            <a:ext cx="91440" cy="91440"/>
+          </a:xfrm>
+          <a:prstGeom prst="ellipse">
+            <a:avLst/>
+          </a:prstGeom>
+          <a:solidFill>
+            <a:srgbClr val="007460"/>
+          </a:solidFill>
+          <a:ln>
+            <a:noFill/>
+          </a:ln>
+        </p:spPr>
+        <p:style>
+          <a:lnRef idx="1">
+            <a:schemeClr val="accent1"/>
+          </a:lnRef>
+          <a:fillRef idx="3">
+            <a:schemeClr val="accent1"/>
+          </a:fillRef>
+          <a:effectRef idx="2">
+            <a:schemeClr val="accent1"/>
+          </a:effectRef>
+          <a:fontRef idx="minor">
+            <a:schemeClr val="lt1"/>
+          </a:fontRef>
+        </p:style>
+        <p:txBody>
+          <a:bodyPr rtlCol="0" anchor="ctr"/>
+          <a:lstStyle/>
+          <a:p>
+            <a:pPr algn="ctr"/>
+          </a:p>
+        </p:txBody>
+      </p:sp>
+      <p:sp>
+        <p:nvSpPr>
+          <p:cNvPr id="15" name="TextBox 14"/>
+          <p:cNvSpPr txBox="1"/>
+          <p:nvPr/>
+        </p:nvSpPr>
+        <p:spPr>
+          <a:xfrm>
+            <a:off x="1554480" y="4892040"/>
+            <a:ext cx="1645920" cy="274320"/>
+          </a:xfrm>
+          <a:prstGeom prst="rect">
+            <a:avLst/>
+          </a:prstGeom>
+          <a:noFill/>
+        </p:spPr>
+        <p:txBody>
+          <a:bodyPr wrap="square">
+            <a:spAutoFit/>
+          </a:bodyPr>
+          <a:lstStyle/>
+          <a:p>
+            <a:pPr algn="l">
+              <a:defRPr sz="1200" b="1">
+                <a:solidFill>
+                  <a:srgbClr val="111827"/>
+                </a:solidFill>
+                <a:latin typeface="Roboto Flex"/>
+              </a:defRPr>
+            </a:pPr>
+            <a:r>
+              <a:t>Opslag-beveiliging</a:t>
+            </a:r>
+          </a:p>
+        </p:txBody>
+      </p:sp>
+      <p:sp>
+        <p:nvSpPr>
+          <p:cNvPr id="16" name="TextBox 15"/>
+          <p:cNvSpPr txBox="1"/>
+          <p:nvPr/>
+        </p:nvSpPr>
+        <p:spPr>
+          <a:xfrm>
+            <a:off x="3291840" y="4892040"/>
+            <a:ext cx="2743200" cy="731520"/>
+          </a:xfrm>
+          <a:prstGeom prst="rect">
+            <a:avLst/>
+          </a:prstGeom>
+          <a:noFill/>
+        </p:spPr>
+        <p:txBody>
+          <a:bodyPr wrap="square">
+            <a:spAutoFit/>
+          </a:bodyPr>
+          <a:lstStyle/>
+          <a:p>
+            <a:pPr algn="l">
+              <a:spcAft>
+                <a:spcPts val="200"/>
+              </a:spcAft>
+              <a:defRPr sz="1000" b="0">
+                <a:solidFill>
+                  <a:srgbClr val="6B7280"/>
+                </a:solidFill>
+                <a:latin typeface="Roboto Flex"/>
+              </a:defRPr>
+            </a:pPr>
+            <a:r>
+              <a:t>PDF-afrekeningen staan in een privé bucket.</a:t>
+            </a:r>
+          </a:p>
+          <a:p>
+            <a:pPr algn="l">
+              <a:spcAft>
+                <a:spcPts val="200"/>
+              </a:spcAft>
+              <a:defRPr sz="1000" b="0">
+                <a:solidFill>
+                  <a:srgbClr val="6B7280"/>
+                </a:solidFill>
+                <a:latin typeface="Roboto Flex"/>
+              </a:defRPr>
+            </a:pPr>
+            <a:r>
+              <a:t>Download alleen mogelijk via tijdelijke signed URLs (verlopen na 5 min).</a:t>
+            </a:r>
+          </a:p>
+          <a:p>
+            <a:pPr algn="l">
+              <a:spcAft>
+                <a:spcPts val="200"/>
+              </a:spcAft>
+              <a:defRPr sz="1000" b="0">
+                <a:solidFill>
+                  <a:srgbClr val="6B7280"/>
+                </a:solidFill>
+                <a:latin typeface="Roboto Flex"/>
+              </a:defRPr>
+            </a:pPr>
+            <a:r>
+              <a:t>Auteurs kunnen enkel bestanden uit hun eigen map openen.</a:t>
+            </a:r>
+          </a:p>
+        </p:txBody>
+      </p:sp>
+      <p:sp>
+        <p:nvSpPr>
+          <p:cNvPr id="17" name="Oval 16"/>
+          <p:cNvSpPr/>
+          <p:nvPr/>
+        </p:nvSpPr>
+        <p:spPr>
+          <a:xfrm>
+            <a:off x="1280160" y="5788152"/>
+            <a:ext cx="91440" cy="91440"/>
+          </a:xfrm>
+          <a:prstGeom prst="ellipse">
+            <a:avLst/>
+          </a:prstGeom>
+          <a:solidFill>
+            <a:srgbClr val="007460"/>
+          </a:solidFill>
+          <a:ln>
+            <a:noFill/>
+          </a:ln>
+        </p:spPr>
+        <p:style>
+          <a:lnRef idx="1">
+            <a:schemeClr val="accent1"/>
+          </a:lnRef>
+          <a:fillRef idx="3">
+            <a:schemeClr val="accent1"/>
+          </a:fillRef>
+          <a:effectRef idx="2">
+            <a:schemeClr val="accent1"/>
+          </a:effectRef>
+          <a:fontRef idx="minor">
+            <a:schemeClr val="lt1"/>
+          </a:fontRef>
+        </p:style>
+        <p:txBody>
+          <a:bodyPr rtlCol="0" anchor="ctr"/>
+          <a:lstStyle/>
+          <a:p>
+            <a:pPr algn="ctr"/>
+          </a:p>
+        </p:txBody>
+      </p:sp>
+      <p:sp>
+        <p:nvSpPr>
+          <p:cNvPr id="18" name="TextBox 17"/>
+          <p:cNvSpPr txBox="1"/>
+          <p:nvPr/>
+        </p:nvSpPr>
+        <p:spPr>
+          <a:xfrm>
+            <a:off x="1554480" y="5715000"/>
+            <a:ext cx="1645920" cy="274320"/>
+          </a:xfrm>
+          <a:prstGeom prst="rect">
+            <a:avLst/>
+          </a:prstGeom>
+          <a:noFill/>
+        </p:spPr>
+        <p:txBody>
+          <a:bodyPr wrap="square">
+            <a:spAutoFit/>
+          </a:bodyPr>
+          <a:lstStyle/>
+          <a:p>
+            <a:pPr algn="l">
+              <a:defRPr sz="1200" b="1">
+                <a:solidFill>
+                  <a:srgbClr val="111827"/>
+                </a:solidFill>
+                <a:latin typeface="Roboto Flex"/>
+              </a:defRPr>
+            </a:pPr>
+            <a:r>
+              <a:t>BSN-maskering</a:t>
+            </a:r>
+          </a:p>
+        </p:txBody>
+      </p:sp>
+      <p:sp>
+        <p:nvSpPr>
+          <p:cNvPr id="19" name="TextBox 18"/>
+          <p:cNvSpPr txBox="1"/>
+          <p:nvPr/>
+        </p:nvSpPr>
+        <p:spPr>
+          <a:xfrm>
+            <a:off x="3291840" y="5715000"/>
+            <a:ext cx="2743200" cy="731520"/>
+          </a:xfrm>
+          <a:prstGeom prst="rect">
+            <a:avLst/>
+          </a:prstGeom>
+          <a:noFill/>
+        </p:spPr>
+        <p:txBody>
+          <a:bodyPr wrap="square">
+            <a:spAutoFit/>
+          </a:bodyPr>
+          <a:lstStyle/>
+          <a:p>
+            <a:pPr algn="l">
+              <a:spcAft>
+                <a:spcPts val="200"/>
+              </a:spcAft>
+              <a:defRPr sz="1000" b="0">
+                <a:solidFill>
+                  <a:srgbClr val="6B7280"/>
+                </a:solidFill>
+                <a:latin typeface="Roboto Flex"/>
+              </a:defRPr>
+            </a:pPr>
+            <a:r>
+              <a:t>Burgerservicenummers worden gemaskeerd weergegeven (•••••6789).</a:t>
+            </a:r>
+          </a:p>
+          <a:p>
+            <a:pPr algn="l">
+              <a:spcAft>
+                <a:spcPts val="200"/>
+              </a:spcAft>
+              <a:defRPr sz="1000" b="0">
+                <a:solidFill>
+                  <a:srgbClr val="6B7280"/>
+                </a:solidFill>
+                <a:latin typeface="Roboto Flex"/>
+              </a:defRPr>
+            </a:pPr>
+            <a:r>
+              <a:t>Pas zichtbaar na expliciete actie van de auteur.</a:t>
+            </a:r>
+          </a:p>
+        </p:txBody>
+      </p:sp>
+      <p:sp>
+        <p:nvSpPr>
+          <p:cNvPr id="20" name="TextBox 19"/>
+          <p:cNvSpPr txBox="1"/>
+          <p:nvPr/>
+        </p:nvSpPr>
+        <p:spPr>
+          <a:xfrm>
+            <a:off x="6583680" y="2011680"/>
+            <a:ext cx="4572000" cy="320040"/>
+          </a:xfrm>
+          <a:prstGeom prst="rect">
+            <a:avLst/>
+          </a:prstGeom>
+          <a:noFill/>
+        </p:spPr>
+        <p:txBody>
+          <a:bodyPr wrap="square">
+            <a:spAutoFit/>
+          </a:bodyPr>
+          <a:lstStyle/>
+          <a:p>
+            <a:pPr algn="l">
+              <a:defRPr sz="1400" b="1">
+                <a:solidFill>
+                  <a:srgbClr val="007460"/>
+                </a:solidFill>
+                <a:latin typeface="Roboto Flex"/>
+              </a:defRPr>
+            </a:pPr>
+            <a:r>
+              <a:t>Fysieke post vs. Portaal</a:t>
+            </a:r>
+          </a:p>
+        </p:txBody>
+      </p:sp>
+      <p:sp>
+        <p:nvSpPr>
+          <p:cNvPr id="21" name="Rounded Rectangle 20"/>
+          <p:cNvSpPr/>
+          <p:nvPr/>
+        </p:nvSpPr>
+        <p:spPr>
+          <a:xfrm>
+            <a:off x="6583680" y="2423160"/>
+            <a:ext cx="4572000" cy="1828800"/>
+          </a:xfrm>
+          <a:prstGeom prst="roundRect">
+            <a:avLst>
+              <a:gd name="adj" fmla="val 4000"/>
+            </a:avLst>
+          </a:prstGeom>
+          <a:solidFill>
+            <a:srgbClr val="FEF2F2"/>
+          </a:solidFill>
+          <a:ln>
+            <a:noFill/>
+          </a:ln>
+        </p:spPr>
+        <p:style>
+          <a:lnRef idx="1">
+            <a:schemeClr val="accent1"/>
+          </a:lnRef>
+          <a:fillRef idx="3">
+            <a:schemeClr val="accent1"/>
+          </a:fillRef>
+          <a:effectRef idx="2">
+            <a:schemeClr val="accent1"/>
+          </a:effectRef>
+          <a:fontRef idx="minor">
+            <a:schemeClr val="lt1"/>
+          </a:fontRef>
+        </p:style>
+        <p:txBody>
+          <a:bodyPr rtlCol="0" anchor="ctr"/>
+          <a:lstStyle/>
+          <a:p>
+            <a:pPr algn="ctr"/>
+          </a:p>
+        </p:txBody>
+      </p:sp>
+      <p:sp>
+        <p:nvSpPr>
+          <p:cNvPr id="22" name="TextBox 21"/>
+          <p:cNvSpPr txBox="1"/>
+          <p:nvPr/>
+        </p:nvSpPr>
+        <p:spPr>
+          <a:xfrm>
+            <a:off x="6858000" y="2514600"/>
+            <a:ext cx="4114800" cy="274320"/>
+          </a:xfrm>
+          <a:prstGeom prst="rect">
+            <a:avLst/>
+          </a:prstGeom>
+          <a:noFill/>
+        </p:spPr>
+        <p:txBody>
+          <a:bodyPr wrap="square">
+            <a:spAutoFit/>
+          </a:bodyPr>
+          <a:lstStyle/>
+          <a:p>
+            <a:pPr algn="l">
+              <a:defRPr sz="1200" b="1">
+                <a:solidFill>
+                  <a:srgbClr val="E8734A"/>
+                </a:solidFill>
+                <a:latin typeface="Roboto Flex"/>
+              </a:defRPr>
+            </a:pPr>
+            <a:r>
+              <a:t>Risico's fysieke post</a:t>
+            </a:r>
+          </a:p>
+        </p:txBody>
+      </p:sp>
+      <p:sp>
+        <p:nvSpPr>
+          <p:cNvPr id="23" name="TextBox 22"/>
+          <p:cNvSpPr txBox="1"/>
+          <p:nvPr/>
+        </p:nvSpPr>
+        <p:spPr>
+          <a:xfrm>
+            <a:off x="6858000" y="2880360"/>
+            <a:ext cx="4023360" cy="274320"/>
+          </a:xfrm>
+          <a:prstGeom prst="rect">
+            <a:avLst/>
+          </a:prstGeom>
+          <a:noFill/>
+        </p:spPr>
+        <p:txBody>
+          <a:bodyPr wrap="square">
+            <a:spAutoFit/>
+          </a:bodyPr>
+          <a:lstStyle/>
+          <a:p>
+            <a:pPr algn="l">
+              <a:defRPr sz="1100" b="0">
+                <a:solidFill>
+                  <a:srgbClr val="6B7280"/>
+                </a:solidFill>
+                <a:latin typeface="Roboto Flex"/>
+              </a:defRPr>
+            </a:pPr>
+            <a:r>
+              <a:t>✗  Brieven met financiële data kunnen zoekraken</a:t>
+            </a:r>
+          </a:p>
+        </p:txBody>
+      </p:sp>
+      <p:sp>
+        <p:nvSpPr>
+          <p:cNvPr id="24" name="TextBox 23"/>
+          <p:cNvSpPr txBox="1"/>
+          <p:nvPr/>
+        </p:nvSpPr>
+        <p:spPr>
+          <a:xfrm>
+            <a:off x="6858000" y="3200400"/>
+            <a:ext cx="4023360" cy="274320"/>
+          </a:xfrm>
+          <a:prstGeom prst="rect">
+            <a:avLst/>
+          </a:prstGeom>
+          <a:noFill/>
+        </p:spPr>
+        <p:txBody>
+          <a:bodyPr wrap="square">
+            <a:spAutoFit/>
+          </a:bodyPr>
+          <a:lstStyle/>
+          <a:p>
+            <a:pPr algn="l">
+              <a:defRPr sz="1100" b="0">
+                <a:solidFill>
+                  <a:srgbClr val="6B7280"/>
+                </a:solidFill>
+                <a:latin typeface="Roboto Flex"/>
+              </a:defRPr>
+            </a:pPr>
+            <a:r>
+              <a:t>✗  Geen controle wie de brief opent</a:t>
+            </a:r>
+          </a:p>
+        </p:txBody>
+      </p:sp>
+      <p:sp>
+        <p:nvSpPr>
+          <p:cNvPr id="25" name="TextBox 24"/>
+          <p:cNvSpPr txBox="1"/>
+          <p:nvPr/>
+        </p:nvSpPr>
+        <p:spPr>
+          <a:xfrm>
+            <a:off x="6858000" y="3520439"/>
+            <a:ext cx="4023360" cy="274320"/>
+          </a:xfrm>
+          <a:prstGeom prst="rect">
+            <a:avLst/>
+          </a:prstGeom>
+          <a:noFill/>
+        </p:spPr>
+        <p:txBody>
+          <a:bodyPr wrap="square">
+            <a:spAutoFit/>
+          </a:bodyPr>
+          <a:lstStyle/>
+          <a:p>
+            <a:pPr algn="l">
+              <a:defRPr sz="1100" b="0">
+                <a:solidFill>
+                  <a:srgbClr val="6B7280"/>
+                </a:solidFill>
+                <a:latin typeface="Roboto Flex"/>
+              </a:defRPr>
+            </a:pPr>
+            <a:r>
+              <a:t>✗  Geen audit trail van toegang</a:t>
+            </a:r>
+          </a:p>
+        </p:txBody>
+      </p:sp>
+      <p:sp>
+        <p:nvSpPr>
+          <p:cNvPr id="26" name="TextBox 25"/>
+          <p:cNvSpPr txBox="1"/>
+          <p:nvPr/>
+        </p:nvSpPr>
+        <p:spPr>
+          <a:xfrm>
+            <a:off x="6858000" y="3840479"/>
+            <a:ext cx="4023360" cy="274320"/>
+          </a:xfrm>
+          <a:prstGeom prst="rect">
+            <a:avLst/>
+          </a:prstGeom>
+          <a:noFill/>
+        </p:spPr>
+        <p:txBody>
+          <a:bodyPr wrap="square">
+            <a:spAutoFit/>
+          </a:bodyPr>
+          <a:lstStyle/>
+          <a:p>
+            <a:pPr algn="l">
+              <a:defRPr sz="1100" b="0">
+                <a:solidFill>
+                  <a:srgbClr val="6B7280"/>
+                </a:solidFill>
+                <a:latin typeface="Roboto Flex"/>
+              </a:defRPr>
+            </a:pPr>
+            <a:r>
+              <a:t>✗  Kopieën blijven liggen op bureaus</a:t>
+            </a:r>
+          </a:p>
+        </p:txBody>
+      </p:sp>
+      <p:sp>
+        <p:nvSpPr>
+          <p:cNvPr id="27" name="Rounded Rectangle 26"/>
+          <p:cNvSpPr/>
+          <p:nvPr/>
+        </p:nvSpPr>
+        <p:spPr>
+          <a:xfrm>
+            <a:off x="6583680" y="4480560"/>
+            <a:ext cx="4572000" cy="2103120"/>
+          </a:xfrm>
+          <a:prstGeom prst="roundRect">
+            <a:avLst>
+              <a:gd name="adj" fmla="val 4000"/>
+            </a:avLst>
+          </a:prstGeom>
+          <a:solidFill>
+            <a:srgbClr val="F0FDF4"/>
+          </a:solidFill>
+          <a:ln>
+            <a:noFill/>
+          </a:ln>
+        </p:spPr>
+        <p:style>
+          <a:lnRef idx="1">
+            <a:schemeClr val="accent1"/>
+          </a:lnRef>
+          <a:fillRef idx="3">
+            <a:schemeClr val="accent1"/>
+          </a:fillRef>
+          <a:effectRef idx="2">
+            <a:schemeClr val="accent1"/>
+          </a:effectRef>
+          <a:fontRef idx="minor">
+            <a:schemeClr val="lt1"/>
+          </a:fontRef>
+        </p:style>
+        <p:txBody>
+          <a:bodyPr rtlCol="0" anchor="ctr"/>
+          <a:lstStyle/>
+          <a:p>
+            <a:pPr algn="ctr"/>
+          </a:p>
+        </p:txBody>
+      </p:sp>
+      <p:sp>
+        <p:nvSpPr>
+          <p:cNvPr id="28" name="TextBox 27"/>
+          <p:cNvSpPr txBox="1"/>
+          <p:nvPr/>
+        </p:nvSpPr>
+        <p:spPr>
+          <a:xfrm>
+            <a:off x="6858000" y="4572000"/>
+            <a:ext cx="4114800" cy="274320"/>
+          </a:xfrm>
+          <a:prstGeom prst="rect">
+            <a:avLst/>
+          </a:prstGeom>
+          <a:noFill/>
+        </p:spPr>
+        <p:txBody>
+          <a:bodyPr wrap="square">
+            <a:spAutoFit/>
+          </a:bodyPr>
+          <a:lstStyle/>
+          <a:p>
+            <a:pPr algn="l">
+              <a:defRPr sz="1200" b="1">
+                <a:solidFill>
+                  <a:srgbClr val="007460"/>
+                </a:solidFill>
+                <a:latin typeface="Roboto Flex"/>
+              </a:defRPr>
+            </a:pPr>
+            <a:r>
+              <a:t>Waarborgen portaal</a:t>
+            </a:r>
+          </a:p>
+        </p:txBody>
+      </p:sp>
+      <p:sp>
+        <p:nvSpPr>
+          <p:cNvPr id="29" name="TextBox 28"/>
+          <p:cNvSpPr txBox="1"/>
+          <p:nvPr/>
+        </p:nvSpPr>
+        <p:spPr>
+          <a:xfrm>
+            <a:off x="6858000" y="4937760"/>
+            <a:ext cx="4023360" cy="274320"/>
+          </a:xfrm>
+          <a:prstGeom prst="rect">
+            <a:avLst/>
+          </a:prstGeom>
+          <a:noFill/>
+        </p:spPr>
+        <p:txBody>
+          <a:bodyPr wrap="square">
+            <a:spAutoFit/>
+          </a:bodyPr>
+          <a:lstStyle/>
+          <a:p>
+            <a:pPr algn="l">
+              <a:defRPr sz="1100" b="0">
+                <a:solidFill>
+                  <a:srgbClr val="111827"/>
+                </a:solidFill>
+                <a:latin typeface="Roboto Flex"/>
+              </a:defRPr>
+            </a:pPr>
+            <a:r>
+              <a:t>✓  Toegang alleen na inloggen met eigen wachtwoord</a:t>
+            </a:r>
+          </a:p>
+        </p:txBody>
+      </p:sp>
+      <p:sp>
+        <p:nvSpPr>
+          <p:cNvPr id="30" name="TextBox 29"/>
+          <p:cNvSpPr txBox="1"/>
+          <p:nvPr/>
+        </p:nvSpPr>
+        <p:spPr>
+          <a:xfrm>
+            <a:off x="6858000" y="5257800"/>
+            <a:ext cx="4023360" cy="274320"/>
+          </a:xfrm>
+          <a:prstGeom prst="rect">
+            <a:avLst/>
+          </a:prstGeom>
+          <a:noFill/>
+        </p:spPr>
+        <p:txBody>
+          <a:bodyPr wrap="square">
+            <a:spAutoFit/>
+          </a:bodyPr>
+          <a:lstStyle/>
+          <a:p>
+            <a:pPr algn="l">
+              <a:defRPr sz="1100" b="0">
+                <a:solidFill>
+                  <a:srgbClr val="111827"/>
+                </a:solidFill>
+                <a:latin typeface="Roboto Flex"/>
+              </a:defRPr>
+            </a:pPr>
+            <a:r>
+              <a:t>✓  Auteur ziet uitsluitend eigen gegevens (RLS)</a:t>
+            </a:r>
+          </a:p>
+        </p:txBody>
+      </p:sp>
+      <p:sp>
+        <p:nvSpPr>
+          <p:cNvPr id="31" name="TextBox 30"/>
+          <p:cNvSpPr txBox="1"/>
+          <p:nvPr/>
+        </p:nvSpPr>
+        <p:spPr>
+          <a:xfrm>
+            <a:off x="6858000" y="5577840"/>
+            <a:ext cx="4023360" cy="274320"/>
+          </a:xfrm>
+          <a:prstGeom prst="rect">
+            <a:avLst/>
+          </a:prstGeom>
+          <a:noFill/>
+        </p:spPr>
+        <p:txBody>
+          <a:bodyPr wrap="square">
+            <a:spAutoFit/>
+          </a:bodyPr>
+          <a:lstStyle/>
+          <a:p>
+            <a:pPr algn="l">
+              <a:defRPr sz="1100" b="0">
+                <a:solidFill>
+                  <a:srgbClr val="111827"/>
+                </a:solidFill>
+                <a:latin typeface="Roboto Flex"/>
+              </a:defRPr>
+            </a:pPr>
+            <a:r>
+              <a:t>✓  Elke login wordt gelogd (audit trail)</a:t>
+            </a:r>
+          </a:p>
+        </p:txBody>
+      </p:sp>
+      <p:sp>
+        <p:nvSpPr>
+          <p:cNvPr id="32" name="TextBox 31"/>
+          <p:cNvSpPr txBox="1"/>
+          <p:nvPr/>
+        </p:nvSpPr>
+        <p:spPr>
+          <a:xfrm>
+            <a:off x="6858000" y="5897880"/>
+            <a:ext cx="4023360" cy="274320"/>
+          </a:xfrm>
+          <a:prstGeom prst="rect">
+            <a:avLst/>
+          </a:prstGeom>
+          <a:noFill/>
+        </p:spPr>
+        <p:txBody>
+          <a:bodyPr wrap="square">
+            <a:spAutoFit/>
+          </a:bodyPr>
+          <a:lstStyle/>
+          <a:p>
+            <a:pPr algn="l">
+              <a:defRPr sz="1100" b="0">
+                <a:solidFill>
+                  <a:srgbClr val="111827"/>
+                </a:solidFill>
+                <a:latin typeface="Roboto Flex"/>
+              </a:defRPr>
+            </a:pPr>
+            <a:r>
+              <a:t>✓  Admin kan verdachte activiteit monitoren</a:t>
+            </a:r>
+          </a:p>
+        </p:txBody>
+      </p:sp>
+      <p:sp>
+        <p:nvSpPr>
+          <p:cNvPr id="33" name="TextBox 32"/>
+          <p:cNvSpPr txBox="1"/>
+          <p:nvPr/>
+        </p:nvSpPr>
+        <p:spPr>
+          <a:xfrm>
+            <a:off x="6858000" y="6217920"/>
+            <a:ext cx="4023360" cy="274320"/>
+          </a:xfrm>
+          <a:prstGeom prst="rect">
+            <a:avLst/>
+          </a:prstGeom>
+          <a:noFill/>
+        </p:spPr>
+        <p:txBody>
+          <a:bodyPr wrap="square">
+            <a:spAutoFit/>
+          </a:bodyPr>
+          <a:lstStyle/>
+          <a:p>
+            <a:pPr algn="l">
+              <a:defRPr sz="1100" b="0">
+                <a:solidFill>
+                  <a:srgbClr val="111827"/>
+                </a:solidFill>
+                <a:latin typeface="Roboto Flex"/>
+              </a:defRPr>
+            </a:pPr>
+            <a:r>
+              <a:t>✓  Geen fysieke documenten die zoekraken</a:t>
+            </a:r>
+          </a:p>
+        </p:txBody>
+      </p:sp>
+    </p:spTree>
+  </p:cSld>
+  <p:clrMapOvr>
+    <a:masterClrMapping/>
+  </p:clrMapOvr>
+</p:sld>
+</file>
+
+<file path=ppt/slides/slide17.xml><?xml version="1.0" encoding="utf-8"?>
+<p:sld xmlns:a="http://schemas.openxmlformats.org/drawingml/2006/main" xmlns:p="http://schemas.openxmlformats.org/presentationml/2006/main" xmlns:r="http://schemas.openxmlformats.org/officeDocument/2006/relationships">
+  <p:cSld>
+    <p:bg>
+      <p:bgPr>
+        <a:solidFill>
+          <a:srgbClr val="FFFFFF"/>
+        </a:solidFill>
+        <a:effectLst/>
+      </p:bgPr>
+    </p:bg>
+    <p:spTree>
+      <p:nvGrpSpPr>
+        <p:cNvPr id="1" name=""/>
+        <p:cNvGrpSpPr/>
+        <p:nvPr/>
+      </p:nvGrpSpPr>
+      <p:grpSpPr/>
+      <p:sp>
+        <p:nvSpPr>
+          <p:cNvPr id="2" name="TextBox 1"/>
+          <p:cNvSpPr txBox="1"/>
+          <p:nvPr/>
+        </p:nvSpPr>
+        <p:spPr>
+          <a:xfrm>
+            <a:off x="1097280" y="640080"/>
+            <a:ext cx="2743200" cy="274320"/>
+          </a:xfrm>
+          <a:prstGeom prst="rect">
+            <a:avLst/>
+          </a:prstGeom>
+          <a:noFill/>
+        </p:spPr>
+        <p:txBody>
+          <a:bodyPr wrap="square">
+            <a:spAutoFit/>
+          </a:bodyPr>
+          <a:lstStyle/>
+          <a:p>
+            <a:pPr algn="l">
+              <a:defRPr sz="1000" b="1">
+                <a:solidFill>
+                  <a:srgbClr val="6B7280"/>
+                </a:solidFill>
+                <a:latin typeface="Roboto Flex"/>
+              </a:defRPr>
+            </a:pPr>
+            <a:r>
+              <a:t>APPENDIX</a:t>
+            </a:r>
+          </a:p>
+        </p:txBody>
+      </p:sp>
+      <p:sp>
+        <p:nvSpPr>
+          <p:cNvPr id="3" name="TextBox 2"/>
+          <p:cNvSpPr txBox="1"/>
+          <p:nvPr/>
+        </p:nvSpPr>
+        <p:spPr>
+          <a:xfrm>
+            <a:off x="1097280" y="1051560"/>
+            <a:ext cx="10058400" cy="914400"/>
+          </a:xfrm>
+          <a:prstGeom prst="rect">
+            <a:avLst/>
+          </a:prstGeom>
+          <a:noFill/>
+        </p:spPr>
+        <p:txBody>
+          <a:bodyPr wrap="square">
+            <a:spAutoFit/>
+          </a:bodyPr>
+          <a:lstStyle/>
+          <a:p>
+            <a:pPr algn="l">
+              <a:defRPr sz="2800" b="1">
+                <a:solidFill>
+                  <a:srgbClr val="007460"/>
+                </a:solidFill>
+                <a:latin typeface="Roboto Flex"/>
+              </a:defRPr>
+            </a:pPr>
+            <a:r>
+              <a:t>AVG-compliance &amp; Privacy</a:t>
+            </a:r>
+          </a:p>
+        </p:txBody>
+      </p:sp>
+      <p:sp>
+        <p:nvSpPr>
+          <p:cNvPr id="4" name="TextBox 3"/>
+          <p:cNvSpPr txBox="1"/>
+          <p:nvPr/>
+        </p:nvSpPr>
+        <p:spPr>
+          <a:xfrm>
+            <a:off x="1097280" y="2011680"/>
+            <a:ext cx="9144000" cy="457200"/>
+          </a:xfrm>
+          <a:prstGeom prst="rect">
+            <a:avLst/>
+          </a:prstGeom>
+          <a:noFill/>
+        </p:spPr>
+        <p:txBody>
+          <a:bodyPr wrap="square">
+            <a:spAutoFit/>
+          </a:bodyPr>
+          <a:lstStyle/>
+          <a:p>
+            <a:pPr algn="l">
+              <a:defRPr sz="1400" b="1">
+                <a:solidFill>
+                  <a:srgbClr val="111827"/>
+                </a:solidFill>
+                <a:latin typeface="Roboto Flex"/>
+              </a:defRPr>
+            </a:pPr>
+            <a:r>
+              <a:t>Hoe het portaal voldoet aan de AVG-uitgangspunten:</a:t>
+            </a:r>
+          </a:p>
+        </p:txBody>
+      </p:sp>
+      <p:sp>
+        <p:nvSpPr>
+          <p:cNvPr id="5" name="Rounded Rectangle 4"/>
+          <p:cNvSpPr/>
+          <p:nvPr/>
+        </p:nvSpPr>
+        <p:spPr>
+          <a:xfrm>
+            <a:off x="1097280" y="2560320"/>
+            <a:ext cx="10058400" cy="713232"/>
+          </a:xfrm>
+          <a:prstGeom prst="roundRect">
+            <a:avLst>
+              <a:gd name="adj" fmla="val 4000"/>
+            </a:avLst>
+          </a:prstGeom>
+          <a:solidFill>
+            <a:srgbClr val="F0FAF7"/>
+          </a:solidFill>
+          <a:ln w="19050">
+            <a:solidFill>
+              <a:srgbClr val="E5E7EB"/>
+            </a:solidFill>
+          </a:ln>
+        </p:spPr>
+        <p:style>
+          <a:lnRef idx="1">
+            <a:schemeClr val="accent1"/>
+          </a:lnRef>
+          <a:fillRef idx="3">
+            <a:schemeClr val="accent1"/>
+          </a:fillRef>
+          <a:effectRef idx="2">
+            <a:schemeClr val="accent1"/>
+          </a:effectRef>
+          <a:fontRef idx="minor">
+            <a:schemeClr val="lt1"/>
+          </a:fontRef>
+        </p:style>
+        <p:txBody>
+          <a:bodyPr rtlCol="0" anchor="ctr"/>
+          <a:lstStyle/>
+          <a:p>
+            <a:pPr algn="ctr"/>
+          </a:p>
+        </p:txBody>
+      </p:sp>
+      <p:sp>
+        <p:nvSpPr>
+          <p:cNvPr id="6" name="TextBox 5"/>
+          <p:cNvSpPr txBox="1"/>
+          <p:nvPr/>
+        </p:nvSpPr>
+        <p:spPr>
+          <a:xfrm>
+            <a:off x="1371600" y="2651760"/>
+            <a:ext cx="2560320" cy="274320"/>
+          </a:xfrm>
+          <a:prstGeom prst="rect">
+            <a:avLst/>
+          </a:prstGeom>
+          <a:noFill/>
+        </p:spPr>
+        <p:txBody>
+          <a:bodyPr wrap="square">
+            <a:spAutoFit/>
+          </a:bodyPr>
+          <a:lstStyle/>
+          <a:p>
+            <a:pPr algn="l">
+              <a:defRPr sz="1100" b="1">
+                <a:solidFill>
+                  <a:srgbClr val="007460"/>
+                </a:solidFill>
+                <a:latin typeface="Roboto Flex"/>
+              </a:defRPr>
+            </a:pPr>
+            <a:r>
+              <a:t>Recht op inzage (Art. 15)</a:t>
+            </a:r>
+          </a:p>
+        </p:txBody>
+      </p:sp>
+      <p:sp>
+        <p:nvSpPr>
+          <p:cNvPr id="7" name="TextBox 6"/>
+          <p:cNvSpPr txBox="1"/>
+          <p:nvPr/>
+        </p:nvSpPr>
+        <p:spPr>
+          <a:xfrm>
+            <a:off x="4114800" y="2651760"/>
+            <a:ext cx="3474720" cy="548640"/>
+          </a:xfrm>
+          <a:prstGeom prst="rect">
+            <a:avLst/>
+          </a:prstGeom>
+          <a:noFill/>
+        </p:spPr>
+        <p:txBody>
+          <a:bodyPr wrap="square">
+            <a:spAutoFit/>
+          </a:bodyPr>
+          <a:lstStyle/>
+          <a:p>
+            <a:pPr algn="l">
+              <a:spcAft>
+                <a:spcPts val="200"/>
+              </a:spcAft>
+              <a:defRPr sz="1000" b="0">
+                <a:solidFill>
+                  <a:srgbClr val="111827"/>
+                </a:solidFill>
+                <a:latin typeface="Roboto Flex"/>
+              </a:defRPr>
+            </a:pPr>
+            <a:r>
+              <a:t>Auteurs kunnen op elk moment hun eigen persoonsgegevens,</a:t>
+            </a:r>
+          </a:p>
+          <a:p>
+            <a:pPr algn="l">
+              <a:spcAft>
+                <a:spcPts val="200"/>
+              </a:spcAft>
+              <a:defRPr sz="1000" b="0">
+                <a:solidFill>
+                  <a:srgbClr val="111827"/>
+                </a:solidFill>
+                <a:latin typeface="Roboto Flex"/>
+              </a:defRPr>
+            </a:pPr>
+            <a:r>
+              <a:t>contracten en afrekeningen inzien via het portaal.</a:t>
+            </a:r>
+          </a:p>
+        </p:txBody>
+      </p:sp>
+      <p:sp>
+        <p:nvSpPr>
+          <p:cNvPr id="8" name="TextBox 7"/>
+          <p:cNvSpPr txBox="1"/>
+          <p:nvPr/>
+        </p:nvSpPr>
+        <p:spPr>
+          <a:xfrm>
+            <a:off x="7772400" y="2651760"/>
+            <a:ext cx="3017520" cy="548640"/>
+          </a:xfrm>
+          <a:prstGeom prst="rect">
+            <a:avLst/>
+          </a:prstGeom>
+          <a:noFill/>
+        </p:spPr>
+        <p:txBody>
+          <a:bodyPr wrap="square">
+            <a:spAutoFit/>
+          </a:bodyPr>
+          <a:lstStyle/>
+          <a:p>
+            <a:pPr algn="l">
+              <a:spcAft>
+                <a:spcPts val="200"/>
+              </a:spcAft>
+              <a:defRPr sz="1000" b="0">
+                <a:solidFill>
+                  <a:srgbClr val="6B7280"/>
+                </a:solidFill>
+                <a:latin typeface="Roboto Flex"/>
+              </a:defRPr>
+            </a:pPr>
+            <a:r>
+              <a:t>Het portaal maakt dit mogelijk zonder</a:t>
+            </a:r>
+          </a:p>
+          <a:p>
+            <a:pPr algn="l">
+              <a:spcAft>
+                <a:spcPts val="200"/>
+              </a:spcAft>
+              <a:defRPr sz="1000" b="0">
+                <a:solidFill>
+                  <a:srgbClr val="6B7280"/>
+                </a:solidFill>
+                <a:latin typeface="Roboto Flex"/>
+              </a:defRPr>
+            </a:pPr>
+            <a:r>
+              <a:t>een formeel verzoek te hoeven indienen.</a:t>
+            </a:r>
+          </a:p>
+        </p:txBody>
+      </p:sp>
+      <p:sp>
+        <p:nvSpPr>
+          <p:cNvPr id="9" name="Rounded Rectangle 8"/>
+          <p:cNvSpPr/>
+          <p:nvPr/>
+        </p:nvSpPr>
+        <p:spPr>
+          <a:xfrm>
+            <a:off x="1097280" y="3364991"/>
+            <a:ext cx="10058400" cy="713232"/>
+          </a:xfrm>
+          <a:prstGeom prst="roundRect">
+            <a:avLst>
+              <a:gd name="adj" fmla="val 4000"/>
+            </a:avLst>
+          </a:prstGeom>
+          <a:solidFill>
+            <a:srgbClr val="FFFFFF"/>
+          </a:solidFill>
+          <a:ln w="19050">
+            <a:solidFill>
+              <a:srgbClr val="E5E7EB"/>
+            </a:solidFill>
+          </a:ln>
+        </p:spPr>
+        <p:style>
+          <a:lnRef idx="1">
+            <a:schemeClr val="accent1"/>
+          </a:lnRef>
+          <a:fillRef idx="3">
+            <a:schemeClr val="accent1"/>
+          </a:fillRef>
+          <a:effectRef idx="2">
+            <a:schemeClr val="accent1"/>
+          </a:effectRef>
+          <a:fontRef idx="minor">
+            <a:schemeClr val="lt1"/>
+          </a:fontRef>
+        </p:style>
+        <p:txBody>
+          <a:bodyPr rtlCol="0" anchor="ctr"/>
+          <a:lstStyle/>
+          <a:p>
+            <a:pPr algn="ctr"/>
+          </a:p>
+        </p:txBody>
+      </p:sp>
+      <p:sp>
+        <p:nvSpPr>
+          <p:cNvPr id="10" name="TextBox 9"/>
+          <p:cNvSpPr txBox="1"/>
+          <p:nvPr/>
+        </p:nvSpPr>
+        <p:spPr>
+          <a:xfrm>
+            <a:off x="1371600" y="3456431"/>
+            <a:ext cx="2560320" cy="274320"/>
+          </a:xfrm>
+          <a:prstGeom prst="rect">
+            <a:avLst/>
+          </a:prstGeom>
+          <a:noFill/>
+        </p:spPr>
+        <p:txBody>
+          <a:bodyPr wrap="square">
+            <a:spAutoFit/>
+          </a:bodyPr>
+          <a:lstStyle/>
+          <a:p>
+            <a:pPr algn="l">
+              <a:defRPr sz="1100" b="1">
+                <a:solidFill>
+                  <a:srgbClr val="007460"/>
+                </a:solidFill>
+                <a:latin typeface="Roboto Flex"/>
+              </a:defRPr>
+            </a:pPr>
+            <a:r>
+              <a:t>Recht op rectificatie (Art. 16)</a:t>
+            </a:r>
+          </a:p>
+        </p:txBody>
+      </p:sp>
+      <p:sp>
+        <p:nvSpPr>
+          <p:cNvPr id="11" name="TextBox 10"/>
+          <p:cNvSpPr txBox="1"/>
+          <p:nvPr/>
+        </p:nvSpPr>
+        <p:spPr>
+          <a:xfrm>
+            <a:off x="4114800" y="3456431"/>
+            <a:ext cx="3474720" cy="548640"/>
+          </a:xfrm>
+          <a:prstGeom prst="rect">
+            <a:avLst/>
+          </a:prstGeom>
+          <a:noFill/>
+        </p:spPr>
+        <p:txBody>
+          <a:bodyPr wrap="square">
+            <a:spAutoFit/>
+          </a:bodyPr>
+          <a:lstStyle/>
+          <a:p>
+            <a:pPr algn="l">
+              <a:spcAft>
+                <a:spcPts val="200"/>
+              </a:spcAft>
+              <a:defRPr sz="1000" b="0">
+                <a:solidFill>
+                  <a:srgbClr val="111827"/>
+                </a:solidFill>
+                <a:latin typeface="Roboto Flex"/>
+              </a:defRPr>
+            </a:pPr>
+            <a:r>
+              <a:t>Auteurs kunnen via het portaal een wijzigingsverzoek</a:t>
+            </a:r>
+          </a:p>
+          <a:p>
+            <a:pPr algn="l">
+              <a:spcAft>
+                <a:spcPts val="200"/>
+              </a:spcAft>
+              <a:defRPr sz="1000" b="0">
+                <a:solidFill>
+                  <a:srgbClr val="111827"/>
+                </a:solidFill>
+                <a:latin typeface="Roboto Flex"/>
+              </a:defRPr>
+            </a:pPr>
+            <a:r>
+              <a:t>indienen voor hun gegevens (adres, telefoon, IBAN).</a:t>
+            </a:r>
+          </a:p>
+        </p:txBody>
+      </p:sp>
+      <p:sp>
+        <p:nvSpPr>
+          <p:cNvPr id="12" name="TextBox 11"/>
+          <p:cNvSpPr txBox="1"/>
+          <p:nvPr/>
+        </p:nvSpPr>
+        <p:spPr>
+          <a:xfrm>
+            <a:off x="7772400" y="3456431"/>
+            <a:ext cx="3017520" cy="548640"/>
+          </a:xfrm>
+          <a:prstGeom prst="rect">
+            <a:avLst/>
+          </a:prstGeom>
+          <a:noFill/>
+        </p:spPr>
+        <p:txBody>
+          <a:bodyPr wrap="square">
+            <a:spAutoFit/>
+          </a:bodyPr>
+          <a:lstStyle/>
+          <a:p>
+            <a:pPr algn="l">
+              <a:spcAft>
+                <a:spcPts val="200"/>
+              </a:spcAft>
+              <a:defRPr sz="1000" b="0">
+                <a:solidFill>
+                  <a:srgbClr val="6B7280"/>
+                </a:solidFill>
+                <a:latin typeface="Roboto Flex"/>
+              </a:defRPr>
+            </a:pPr>
+            <a:r>
+              <a:t>Admin keurt goed of wijst af —</a:t>
+            </a:r>
+          </a:p>
+          <a:p>
+            <a:pPr algn="l">
+              <a:spcAft>
+                <a:spcPts val="200"/>
+              </a:spcAft>
+              <a:defRPr sz="1000" b="0">
+                <a:solidFill>
+                  <a:srgbClr val="6B7280"/>
+                </a:solidFill>
+                <a:latin typeface="Roboto Flex"/>
+              </a:defRPr>
+            </a:pPr>
+            <a:r>
+              <a:t>volledig traceerbaar.</a:t>
+            </a:r>
+          </a:p>
+        </p:txBody>
+      </p:sp>
+      <p:sp>
+        <p:nvSpPr>
+          <p:cNvPr id="13" name="Rounded Rectangle 12"/>
+          <p:cNvSpPr/>
+          <p:nvPr/>
+        </p:nvSpPr>
+        <p:spPr>
+          <a:xfrm>
+            <a:off x="1097280" y="4169663"/>
+            <a:ext cx="10058400" cy="713232"/>
+          </a:xfrm>
+          <a:prstGeom prst="roundRect">
+            <a:avLst>
+              <a:gd name="adj" fmla="val 4000"/>
+            </a:avLst>
+          </a:prstGeom>
+          <a:solidFill>
+            <a:srgbClr val="F0FAF7"/>
+          </a:solidFill>
+          <a:ln w="19050">
+            <a:solidFill>
+              <a:srgbClr val="E5E7EB"/>
+            </a:solidFill>
+          </a:ln>
+        </p:spPr>
+        <p:style>
+          <a:lnRef idx="1">
+            <a:schemeClr val="accent1"/>
+          </a:lnRef>
+          <a:fillRef idx="3">
+            <a:schemeClr val="accent1"/>
+          </a:fillRef>
+          <a:effectRef idx="2">
+            <a:schemeClr val="accent1"/>
+          </a:effectRef>
+          <a:fontRef idx="minor">
+            <a:schemeClr val="lt1"/>
+          </a:fontRef>
+        </p:style>
+        <p:txBody>
+          <a:bodyPr rtlCol="0" anchor="ctr"/>
+          <a:lstStyle/>
+          <a:p>
+            <a:pPr algn="ctr"/>
+          </a:p>
+        </p:txBody>
+      </p:sp>
+      <p:sp>
+        <p:nvSpPr>
+          <p:cNvPr id="14" name="TextBox 13"/>
+          <p:cNvSpPr txBox="1"/>
+          <p:nvPr/>
+        </p:nvSpPr>
+        <p:spPr>
+          <a:xfrm>
+            <a:off x="1371600" y="4261103"/>
+            <a:ext cx="2560320" cy="274320"/>
+          </a:xfrm>
+          <a:prstGeom prst="rect">
+            <a:avLst/>
+          </a:prstGeom>
+          <a:noFill/>
+        </p:spPr>
+        <p:txBody>
+          <a:bodyPr wrap="square">
+            <a:spAutoFit/>
+          </a:bodyPr>
+          <a:lstStyle/>
+          <a:p>
+            <a:pPr algn="l">
+              <a:defRPr sz="1100" b="1">
+                <a:solidFill>
+                  <a:srgbClr val="007460"/>
+                </a:solidFill>
+                <a:latin typeface="Roboto Flex"/>
+              </a:defRPr>
+            </a:pPr>
+            <a:r>
+              <a:t>Dataminimalisatie (Art. 5)</a:t>
+            </a:r>
+          </a:p>
+        </p:txBody>
+      </p:sp>
+      <p:sp>
+        <p:nvSpPr>
+          <p:cNvPr id="15" name="TextBox 14"/>
+          <p:cNvSpPr txBox="1"/>
+          <p:nvPr/>
+        </p:nvSpPr>
+        <p:spPr>
+          <a:xfrm>
+            <a:off x="4114800" y="4261103"/>
+            <a:ext cx="3474720" cy="548640"/>
+          </a:xfrm>
+          <a:prstGeom prst="rect">
+            <a:avLst/>
+          </a:prstGeom>
+          <a:noFill/>
+        </p:spPr>
+        <p:txBody>
+          <a:bodyPr wrap="square">
+            <a:spAutoFit/>
+          </a:bodyPr>
+          <a:lstStyle/>
+          <a:p>
+            <a:pPr algn="l">
+              <a:spcAft>
+                <a:spcPts val="200"/>
+              </a:spcAft>
+              <a:defRPr sz="1000" b="0">
+                <a:solidFill>
+                  <a:srgbClr val="111827"/>
+                </a:solidFill>
+                <a:latin typeface="Roboto Flex"/>
+              </a:defRPr>
+            </a:pPr>
+            <a:r>
+              <a:t>Het portaal toont alleen relevante gegevens.</a:t>
+            </a:r>
+          </a:p>
+          <a:p>
+            <a:pPr algn="l">
+              <a:spcAft>
+                <a:spcPts val="200"/>
+              </a:spcAft>
+              <a:defRPr sz="1000" b="0">
+                <a:solidFill>
+                  <a:srgbClr val="111827"/>
+                </a:solidFill>
+                <a:latin typeface="Roboto Flex"/>
+              </a:defRPr>
+            </a:pPr>
+            <a:r>
+              <a:t>BSN is standaard gemaskeerd.</a:t>
+            </a:r>
+          </a:p>
+        </p:txBody>
+      </p:sp>
+      <p:sp>
+        <p:nvSpPr>
+          <p:cNvPr id="16" name="TextBox 15"/>
+          <p:cNvSpPr txBox="1"/>
+          <p:nvPr/>
+        </p:nvSpPr>
+        <p:spPr>
+          <a:xfrm>
+            <a:off x="7772400" y="4261103"/>
+            <a:ext cx="3017520" cy="548640"/>
+          </a:xfrm>
+          <a:prstGeom prst="rect">
+            <a:avLst/>
+          </a:prstGeom>
+          <a:noFill/>
+        </p:spPr>
+        <p:txBody>
+          <a:bodyPr wrap="square">
+            <a:spAutoFit/>
+          </a:bodyPr>
+          <a:lstStyle/>
+          <a:p>
+            <a:pPr algn="l">
+              <a:spcAft>
+                <a:spcPts val="200"/>
+              </a:spcAft>
+              <a:defRPr sz="1000" b="0">
+                <a:solidFill>
+                  <a:srgbClr val="6B7280"/>
+                </a:solidFill>
+                <a:latin typeface="Roboto Flex"/>
+              </a:defRPr>
+            </a:pPr>
+            <a:r>
+              <a:t>Geen onnodige data-opslag</a:t>
+            </a:r>
+          </a:p>
+          <a:p>
+            <a:pPr algn="l">
+              <a:spcAft>
+                <a:spcPts val="200"/>
+              </a:spcAft>
+              <a:defRPr sz="1000" b="0">
+                <a:solidFill>
+                  <a:srgbClr val="6B7280"/>
+                </a:solidFill>
+                <a:latin typeface="Roboto Flex"/>
+              </a:defRPr>
+            </a:pPr>
+            <a:r>
+              <a:t>of -verspreiding.</a:t>
+            </a:r>
+          </a:p>
+        </p:txBody>
+      </p:sp>
+      <p:sp>
+        <p:nvSpPr>
+          <p:cNvPr id="17" name="Rounded Rectangle 16"/>
+          <p:cNvSpPr/>
+          <p:nvPr/>
+        </p:nvSpPr>
+        <p:spPr>
+          <a:xfrm>
+            <a:off x="1097280" y="4974336"/>
+            <a:ext cx="10058400" cy="713232"/>
+          </a:xfrm>
+          <a:prstGeom prst="roundRect">
+            <a:avLst>
+              <a:gd name="adj" fmla="val 4000"/>
+            </a:avLst>
+          </a:prstGeom>
+          <a:solidFill>
+            <a:srgbClr val="FFFFFF"/>
+          </a:solidFill>
+          <a:ln w="19050">
+            <a:solidFill>
+              <a:srgbClr val="E5E7EB"/>
+            </a:solidFill>
+          </a:ln>
+        </p:spPr>
+        <p:style>
+          <a:lnRef idx="1">
+            <a:schemeClr val="accent1"/>
+          </a:lnRef>
+          <a:fillRef idx="3">
+            <a:schemeClr val="accent1"/>
+          </a:fillRef>
+          <a:effectRef idx="2">
+            <a:schemeClr val="accent1"/>
+          </a:effectRef>
+          <a:fontRef idx="minor">
+            <a:schemeClr val="lt1"/>
+          </a:fontRef>
+        </p:style>
+        <p:txBody>
+          <a:bodyPr rtlCol="0" anchor="ctr"/>
+          <a:lstStyle/>
+          <a:p>
+            <a:pPr algn="ctr"/>
+          </a:p>
+        </p:txBody>
+      </p:sp>
+      <p:sp>
+        <p:nvSpPr>
+          <p:cNvPr id="18" name="TextBox 17"/>
+          <p:cNvSpPr txBox="1"/>
+          <p:nvPr/>
+        </p:nvSpPr>
+        <p:spPr>
+          <a:xfrm>
+            <a:off x="1371600" y="5065776"/>
+            <a:ext cx="2560320" cy="274320"/>
+          </a:xfrm>
+          <a:prstGeom prst="rect">
+            <a:avLst/>
+          </a:prstGeom>
+          <a:noFill/>
+        </p:spPr>
+        <p:txBody>
+          <a:bodyPr wrap="square">
+            <a:spAutoFit/>
+          </a:bodyPr>
+          <a:lstStyle/>
+          <a:p>
+            <a:pPr algn="l">
+              <a:defRPr sz="1100" b="1">
+                <a:solidFill>
+                  <a:srgbClr val="007460"/>
+                </a:solidFill>
+                <a:latin typeface="Roboto Flex"/>
+              </a:defRPr>
+            </a:pPr>
+            <a:r>
+              <a:t>Beveiliging (Art. 32)</a:t>
+            </a:r>
+          </a:p>
+        </p:txBody>
+      </p:sp>
+      <p:sp>
+        <p:nvSpPr>
+          <p:cNvPr id="19" name="TextBox 18"/>
+          <p:cNvSpPr txBox="1"/>
+          <p:nvPr/>
+        </p:nvSpPr>
+        <p:spPr>
+          <a:xfrm>
+            <a:off x="4114800" y="5065776"/>
+            <a:ext cx="3474720" cy="548640"/>
+          </a:xfrm>
+          <a:prstGeom prst="rect">
+            <a:avLst/>
+          </a:prstGeom>
+          <a:noFill/>
+        </p:spPr>
+        <p:txBody>
+          <a:bodyPr wrap="square">
+            <a:spAutoFit/>
+          </a:bodyPr>
+          <a:lstStyle/>
+          <a:p>
+            <a:pPr algn="l">
+              <a:spcAft>
+                <a:spcPts val="200"/>
+              </a:spcAft>
+              <a:defRPr sz="1000" b="0">
+                <a:solidFill>
+                  <a:srgbClr val="111827"/>
+                </a:solidFill>
+                <a:latin typeface="Roboto Flex"/>
+              </a:defRPr>
+            </a:pPr>
+            <a:r>
+              <a:t>Versleutelde verbindingen, gehashte wachtwoorden,</a:t>
+            </a:r>
+          </a:p>
+          <a:p>
+            <a:pPr algn="l">
+              <a:spcAft>
+                <a:spcPts val="200"/>
+              </a:spcAft>
+              <a:defRPr sz="1000" b="0">
+                <a:solidFill>
+                  <a:srgbClr val="111827"/>
+                </a:solidFill>
+                <a:latin typeface="Roboto Flex"/>
+              </a:defRPr>
+            </a:pPr>
+            <a:r>
+              <a:t>Row Level Security, signed URLs voor downloads.</a:t>
+            </a:r>
+          </a:p>
+        </p:txBody>
+      </p:sp>
+      <p:sp>
+        <p:nvSpPr>
+          <p:cNvPr id="20" name="TextBox 19"/>
+          <p:cNvSpPr txBox="1"/>
+          <p:nvPr/>
+        </p:nvSpPr>
+        <p:spPr>
+          <a:xfrm>
+            <a:off x="7772400" y="5065776"/>
+            <a:ext cx="3017520" cy="548640"/>
+          </a:xfrm>
+          <a:prstGeom prst="rect">
+            <a:avLst/>
+          </a:prstGeom>
+          <a:noFill/>
+        </p:spPr>
+        <p:txBody>
+          <a:bodyPr wrap="square">
+            <a:spAutoFit/>
+          </a:bodyPr>
+          <a:lstStyle/>
+          <a:p>
+            <a:pPr algn="l">
+              <a:spcAft>
+                <a:spcPts val="200"/>
+              </a:spcAft>
+              <a:defRPr sz="1000" b="0">
+                <a:solidFill>
+                  <a:srgbClr val="6B7280"/>
+                </a:solidFill>
+                <a:latin typeface="Roboto Flex"/>
+              </a:defRPr>
+            </a:pPr>
+            <a:r>
+              <a:t>Technische en organisatorische</a:t>
+            </a:r>
+          </a:p>
+          <a:p>
+            <a:pPr algn="l">
+              <a:spcAft>
+                <a:spcPts val="200"/>
+              </a:spcAft>
+              <a:defRPr sz="1000" b="0">
+                <a:solidFill>
+                  <a:srgbClr val="6B7280"/>
+                </a:solidFill>
+                <a:latin typeface="Roboto Flex"/>
+              </a:defRPr>
+            </a:pPr>
+            <a:r>
+              <a:t>maatregelen zijn ingebouwd.</a:t>
+            </a:r>
+          </a:p>
+        </p:txBody>
+      </p:sp>
+      <p:sp>
+        <p:nvSpPr>
+          <p:cNvPr id="21" name="Rounded Rectangle 20"/>
+          <p:cNvSpPr/>
+          <p:nvPr/>
+        </p:nvSpPr>
+        <p:spPr>
+          <a:xfrm>
+            <a:off x="1097280" y="5779008"/>
+            <a:ext cx="10058400" cy="713232"/>
+          </a:xfrm>
+          <a:prstGeom prst="roundRect">
+            <a:avLst>
+              <a:gd name="adj" fmla="val 4000"/>
+            </a:avLst>
+          </a:prstGeom>
+          <a:solidFill>
+            <a:srgbClr val="F0FAF7"/>
+          </a:solidFill>
+          <a:ln w="19050">
+            <a:solidFill>
+              <a:srgbClr val="E5E7EB"/>
+            </a:solidFill>
+          </a:ln>
+        </p:spPr>
+        <p:style>
+          <a:lnRef idx="1">
+            <a:schemeClr val="accent1"/>
+          </a:lnRef>
+          <a:fillRef idx="3">
+            <a:schemeClr val="accent1"/>
+          </a:fillRef>
+          <a:effectRef idx="2">
+            <a:schemeClr val="accent1"/>
+          </a:effectRef>
+          <a:fontRef idx="minor">
+            <a:schemeClr val="lt1"/>
+          </a:fontRef>
+        </p:style>
+        <p:txBody>
+          <a:bodyPr rtlCol="0" anchor="ctr"/>
+          <a:lstStyle/>
+          <a:p>
+            <a:pPr algn="ctr"/>
+          </a:p>
+        </p:txBody>
+      </p:sp>
+      <p:sp>
+        <p:nvSpPr>
+          <p:cNvPr id="22" name="TextBox 21"/>
+          <p:cNvSpPr txBox="1"/>
+          <p:nvPr/>
+        </p:nvSpPr>
+        <p:spPr>
+          <a:xfrm>
+            <a:off x="1371600" y="5870448"/>
+            <a:ext cx="2560320" cy="274320"/>
+          </a:xfrm>
+          <a:prstGeom prst="rect">
+            <a:avLst/>
+          </a:prstGeom>
+          <a:noFill/>
+        </p:spPr>
+        <p:txBody>
+          <a:bodyPr wrap="square">
+            <a:spAutoFit/>
+          </a:bodyPr>
+          <a:lstStyle/>
+          <a:p>
+            <a:pPr algn="l">
+              <a:defRPr sz="1100" b="1">
+                <a:solidFill>
+                  <a:srgbClr val="007460"/>
+                </a:solidFill>
+                <a:latin typeface="Roboto Flex"/>
+              </a:defRPr>
+            </a:pPr>
+            <a:r>
+              <a:t>Logging &amp; verantwoording (Art. 5)</a:t>
+            </a:r>
+          </a:p>
+        </p:txBody>
+      </p:sp>
+      <p:sp>
+        <p:nvSpPr>
+          <p:cNvPr id="23" name="TextBox 22"/>
+          <p:cNvSpPr txBox="1"/>
+          <p:nvPr/>
+        </p:nvSpPr>
+        <p:spPr>
+          <a:xfrm>
+            <a:off x="4114800" y="5870448"/>
+            <a:ext cx="3474720" cy="548640"/>
+          </a:xfrm>
+          <a:prstGeom prst="rect">
+            <a:avLst/>
+          </a:prstGeom>
+          <a:noFill/>
+        </p:spPr>
+        <p:txBody>
+          <a:bodyPr wrap="square">
+            <a:spAutoFit/>
+          </a:bodyPr>
+          <a:lstStyle/>
+          <a:p>
+            <a:pPr algn="l">
+              <a:spcAft>
+                <a:spcPts val="200"/>
+              </a:spcAft>
+              <a:defRPr sz="1000" b="0">
+                <a:solidFill>
+                  <a:srgbClr val="111827"/>
+                </a:solidFill>
+                <a:latin typeface="Roboto Flex"/>
+              </a:defRPr>
+            </a:pPr>
+            <a:r>
+              <a:t>Alle logins worden geregistreerd. Wijzigingsverzoeken</a:t>
+            </a:r>
+          </a:p>
+          <a:p>
+            <a:pPr algn="l">
+              <a:spcAft>
+                <a:spcPts val="200"/>
+              </a:spcAft>
+              <a:defRPr sz="1000" b="0">
+                <a:solidFill>
+                  <a:srgbClr val="111827"/>
+                </a:solidFill>
+                <a:latin typeface="Roboto Flex"/>
+              </a:defRPr>
+            </a:pPr>
+            <a:r>
+              <a:t>hebben een volledige audit trail met timestamps.</a:t>
+            </a:r>
+          </a:p>
+        </p:txBody>
+      </p:sp>
+      <p:sp>
+        <p:nvSpPr>
+          <p:cNvPr id="24" name="TextBox 23"/>
+          <p:cNvSpPr txBox="1"/>
+          <p:nvPr/>
+        </p:nvSpPr>
+        <p:spPr>
+          <a:xfrm>
+            <a:off x="7772400" y="5870448"/>
+            <a:ext cx="3017520" cy="548640"/>
+          </a:xfrm>
+          <a:prstGeom prst="rect">
+            <a:avLst/>
+          </a:prstGeom>
+          <a:noFill/>
+        </p:spPr>
+        <p:txBody>
+          <a:bodyPr wrap="square">
+            <a:spAutoFit/>
+          </a:bodyPr>
+          <a:lstStyle/>
+          <a:p>
+            <a:pPr algn="l">
+              <a:spcAft>
+                <a:spcPts val="200"/>
+              </a:spcAft>
+              <a:defRPr sz="1000" b="0">
+                <a:solidFill>
+                  <a:srgbClr val="6B7280"/>
+                </a:solidFill>
+                <a:latin typeface="Roboto Flex"/>
+              </a:defRPr>
+            </a:pPr>
+            <a:r>
+              <a:t>Bij een audit is exact</a:t>
+            </a:r>
+          </a:p>
+          <a:p>
+            <a:pPr algn="l">
+              <a:spcAft>
+                <a:spcPts val="200"/>
+              </a:spcAft>
+              <a:defRPr sz="1000" b="0">
+                <a:solidFill>
+                  <a:srgbClr val="6B7280"/>
+                </a:solidFill>
+                <a:latin typeface="Roboto Flex"/>
+              </a:defRPr>
+            </a:pPr>
+            <a:r>
+              <a:t>traceerbaar wie wat heeft gedaan.</a:t>
+            </a:r>
+          </a:p>
+        </p:txBody>
+      </p:sp>
+      <p:sp>
+        <p:nvSpPr>
+          <p:cNvPr id="25" name="TextBox 24"/>
+          <p:cNvSpPr txBox="1"/>
+          <p:nvPr/>
+        </p:nvSpPr>
+        <p:spPr>
+          <a:xfrm>
+            <a:off x="1097280" y="6492240"/>
+            <a:ext cx="10058400" cy="274320"/>
+          </a:xfrm>
+          <a:prstGeom prst="rect">
+            <a:avLst/>
+          </a:prstGeom>
+          <a:noFill/>
+        </p:spPr>
+        <p:txBody>
+          <a:bodyPr wrap="square">
+            <a:spAutoFit/>
+          </a:bodyPr>
+          <a:lstStyle/>
+          <a:p>
+            <a:pPr algn="ctr">
+              <a:defRPr sz="1100" b="1">
+                <a:solidFill>
+                  <a:srgbClr val="007460"/>
+                </a:solidFill>
+                <a:latin typeface="Roboto Flex"/>
+              </a:defRPr>
+            </a:pPr>
+            <a:r>
+              <a:t>Het portaal vervangt fysieke brieven — dit vermindert het risico op datalekken en verbetert de compliance-positie.</a:t>
+            </a:r>
+          </a:p>
+        </p:txBody>
+      </p:sp>
+    </p:spTree>
+  </p:cSld>
+  <p:clrMapOvr>
+    <a:masterClrMapping/>
+  </p:clrMapOvr>
+</p:sld>
+</file>
+
 <file path=ppt/slides/slide2.xml><?xml version="1.0" encoding="utf-8"?>
 <p:sld xmlns:a="http://schemas.openxmlformats.org/drawingml/2006/main" xmlns:p="http://schemas.openxmlformats.org/presentationml/2006/main" xmlns:r="http://schemas.openxmlformats.org/officeDocument/2006/relationships">
   <p:cSld>

</xml_diff>